<commit_message>
docs(training): jelasnya easter egg Finish di deck
</commit_message>
<xml_diff>
--- a/docs/training/RoomBooking-Panduan-CMS-Tablet.pptx
+++ b/docs/training/RoomBooking-Panduan-CMS-Tablet.pptx
@@ -17,6 +17,7 @@
     <p:sldId id="265" r:id="rId17"/>
     <p:sldId id="266" r:id="rId18"/>
     <p:sldId id="267" r:id="rId19"/>
+    <p:sldId id="272" r:id="rId24"/>
     <p:sldId id="268" r:id="rId20"/>
     <p:sldId id="269" r:id="rId21"/>
     <p:sldId id="270" r:id="rId22"/>
@@ -1008,6 +1009,76 @@
           <a:p>
             <a:r>
               <a:t>Tutup dengan menegaskan siapa yang dihubungi dan di mana panduan disimpan. Jangan mencantumkan password atau data pribadi di versi cetak.</a:t>
+            </a:r>
+          </a:p>
+        </p:txBody>
+      </p:sp>
+      <p:sp>
+        <p:nvSpPr>
+          <p:cNvPr id="4" name="Slide Number Placeholder 3"/>
+          <p:cNvSpPr>
+            <a:spLocks noGrp="1"/>
+          </p:cNvSpPr>
+          <p:nvPr>
+            <p:ph type="sldNum" idx="5" sz="quarter"/>
+          </p:nvPr>
+        </p:nvSpPr>
+        <p:spPr/>
+      </p:sp>
+    </p:spTree>
+  </p:cSld>
+  <p:clrMapOvr>
+    <a:masterClrMapping/>
+  </p:clrMapOvr>
+</p:notes>
+</file>
+
+<file path=ppt/notesSlides/notesSlide17.xml><?xml version="1.0" encoding="utf-8"?>
+<p:notes xmlns:a="http://schemas.openxmlformats.org/drawingml/2006/main" xmlns:p="http://schemas.openxmlformats.org/presentationml/2006/main" xmlns:r="http://schemas.openxmlformats.org/officeDocument/2006/relationships">
+  <p:cSld>
+    <p:spTree>
+      <p:nvGrpSpPr>
+        <p:cNvPr id="1" name=""/>
+        <p:cNvGrpSpPr/>
+        <p:nvPr/>
+      </p:nvGrpSpPr>
+      <p:grpSpPr>
+        <a:xfrm>
+          <a:off x="0" y="0"/>
+          <a:ext cx="0" cy="0"/>
+          <a:chOff x="0" y="0"/>
+          <a:chExt cx="0" cy="0"/>
+        </a:xfrm>
+      </p:grpSpPr>
+      <p:sp>
+        <p:nvSpPr>
+          <p:cNvPr id="2" name="Slide Image Placeholder 1"/>
+          <p:cNvSpPr>
+            <a:spLocks noGrp="1"/>
+          </p:cNvSpPr>
+          <p:nvPr>
+            <p:ph type="sldImg" idx="2"/>
+          </p:nvPr>
+        </p:nvSpPr>
+        <p:spPr/>
+      </p:sp>
+      <p:sp>
+        <p:nvSpPr>
+          <p:cNvPr id="3" name="Notes Placeholder 2"/>
+          <p:cNvSpPr>
+            <a:spLocks noGrp="1"/>
+          </p:cNvSpPr>
+          <p:nvPr>
+            <p:ph type="body" idx="3" sz="quarter"/>
+          </p:nvPr>
+        </p:nvSpPr>
+        <p:spPr/>
+        <p:txBody>
+          <a:bodyPr/>
+          <a:lstStyle/>
+          <a:p>
+            <a:r>
+              <a:t>Jelaskan bahwa tombol Selesai memang disembunyikan (easter egg) untuk mencegah anggota rapat menyelesaikan meeting orang lain secara tidak sengaja. Syarat: sudah check-in dan meeting sudah berjalan. Jika check-in terlalu awal, kiosk menampilkan waktu tombol Selesai aktif. Jangan memaksa tutup aplikasi.</a:t>
             </a:r>
           </a:p>
         </p:txBody>
@@ -5557,7 +5628,7 @@
                 </a:solidFill>
                 <a:latin typeface="Arial"/>
               </a:rPr>
-              <a:t>10 / 16</a:t>
+              <a:t>10 / 17</a:t>
             </a:r>
           </a:p>
         </p:txBody>
@@ -6275,7 +6346,7 @@
                 </a:solidFill>
                 <a:latin typeface="Arial"/>
               </a:rPr>
-              <a:t>11 / 16</a:t>
+              <a:t>11 / 17</a:t>
             </a:r>
           </a:p>
         </p:txBody>
@@ -7129,7 +7200,7 @@
                 </a:solidFill>
                 <a:latin typeface="Arial"/>
               </a:rPr>
-              <a:t>12 / 16</a:t>
+              <a:t>12 / 17</a:t>
             </a:r>
           </a:p>
         </p:txBody>
@@ -7779,7 +7850,7 @@
                 </a:solidFill>
                 <a:latin typeface="Arial"/>
               </a:rPr>
-              <a:t>13 / 16</a:t>
+              <a:t>14 / 17</a:t>
             </a:r>
           </a:p>
         </p:txBody>
@@ -8329,7 +8400,7 @@
                 </a:solidFill>
                 <a:latin typeface="Arial"/>
               </a:rPr>
-              <a:t>14 / 16</a:t>
+              <a:t>15 / 17</a:t>
             </a:r>
           </a:p>
         </p:txBody>
@@ -9219,7 +9290,7 @@
                 </a:solidFill>
                 <a:latin typeface="Arial"/>
               </a:rPr>
-              <a:t>15 / 16</a:t>
+              <a:t>16 / 17</a:t>
             </a:r>
           </a:p>
         </p:txBody>
@@ -10760,6 +10831,592 @@
 </p:sld>
 </file>
 
+<file path=ppt/slides/slide17.xml><?xml version="1.0" encoding="utf-8"?>
+<p:sld xmlns:a="http://schemas.openxmlformats.org/drawingml/2006/main" xmlns:p="http://schemas.openxmlformats.org/presentationml/2006/main" xmlns:r="http://schemas.openxmlformats.org/officeDocument/2006/relationships">
+  <p:cSld>
+    <p:bg>
+      <p:bgPr>
+        <a:solidFill>
+          <a:srgbClr val="11151B"/>
+        </a:solidFill>
+        <a:effectLst/>
+      </p:bgPr>
+    </p:bg>
+    <p:spTree>
+      <p:nvGrpSpPr>
+        <p:cNvPr id="1" name=""/>
+        <p:cNvGrpSpPr/>
+        <p:nvPr/>
+      </p:nvGrpSpPr>
+      <p:grpSpPr/>
+      <p:sp>
+        <p:nvSpPr>
+          <p:cNvPr id="2" name="TextBox 1"/>
+          <p:cNvSpPr txBox="1"/>
+          <p:nvPr/>
+        </p:nvSpPr>
+        <p:spPr>
+          <a:xfrm>
+            <a:off x="548640" y="320040"/>
+            <a:ext cx="10058400" cy="365760"/>
+          </a:xfrm>
+          <a:prstGeom prst="rect">
+            <a:avLst/>
+          </a:prstGeom>
+          <a:noFill/>
+        </p:spPr>
+        <p:txBody>
+          <a:bodyPr wrap="square">
+            <a:spAutoFit/>
+          </a:bodyPr>
+          <a:lstStyle/>
+          <a:p>
+            <a:pPr>
+              <a:defRPr sz="1200" b="1">
+                <a:solidFill>
+                  <a:srgbClr val="3DDC84"/>
+                </a:solidFill>
+                <a:latin typeface="Arial"/>
+              </a:defRPr>
+            </a:pPr>
+            <a:r>
+              <a:t>TABLET · FINISH</a:t>
+            </a:r>
+          </a:p>
+        </p:txBody>
+      </p:sp>
+      <p:sp>
+        <p:nvSpPr>
+          <p:cNvPr id="3" name="TextBox 2"/>
+          <p:cNvSpPr txBox="1"/>
+          <p:nvPr/>
+        </p:nvSpPr>
+        <p:spPr>
+          <a:xfrm>
+            <a:off x="548640" y="685800"/>
+            <a:ext cx="10972800" cy="640080"/>
+          </a:xfrm>
+          <a:prstGeom prst="rect">
+            <a:avLst/>
+          </a:prstGeom>
+          <a:noFill/>
+        </p:spPr>
+        <p:txBody>
+          <a:bodyPr wrap="square">
+            <a:spAutoFit/>
+          </a:bodyPr>
+          <a:lstStyle/>
+          <a:p>
+            <a:pPr>
+              <a:defRPr sz="3000" b="1">
+                <a:solidFill>
+                  <a:srgbClr val="F4F6F8"/>
+                </a:solidFill>
+                <a:latin typeface="Arial"/>
+              </a:defRPr>
+            </a:pPr>
+            <a:r>
+              <a:t>Easter egg: tombol Selesai tidak terlihat</a:t>
+            </a:r>
+          </a:p>
+        </p:txBody>
+      </p:sp>
+      <p:sp>
+        <p:nvSpPr>
+          <p:cNvPr id="4" name="TextBox 3"/>
+          <p:cNvSpPr txBox="1"/>
+          <p:nvPr/>
+        </p:nvSpPr>
+        <p:spPr>
+          <a:xfrm>
+            <a:off x="548640" y="1417320"/>
+            <a:ext cx="5760720" cy="411480"/>
+          </a:xfrm>
+          <a:prstGeom prst="rect">
+            <a:avLst/>
+          </a:prstGeom>
+          <a:noFill/>
+        </p:spPr>
+        <p:txBody>
+          <a:bodyPr wrap="square">
+            <a:spAutoFit/>
+          </a:bodyPr>
+          <a:lstStyle/>
+          <a:p>
+            <a:pPr>
+              <a:defRPr sz="1800" b="1">
+                <a:solidFill>
+                  <a:srgbClr val="FFD25A"/>
+                </a:solidFill>
+                <a:latin typeface="Arial"/>
+              </a:defRPr>
+            </a:pPr>
+            <a:r>
+              <a:t>5 tap pada pill IN USE — bukan tombol biasa</a:t>
+            </a:r>
+          </a:p>
+        </p:txBody>
+      </p:sp>
+      <p:sp>
+        <p:nvSpPr>
+          <p:cNvPr id="5" name="TextBox 4"/>
+          <p:cNvSpPr txBox="1"/>
+          <p:nvPr/>
+        </p:nvSpPr>
+        <p:spPr>
+          <a:xfrm>
+            <a:off x="594360" y="2011680"/>
+            <a:ext cx="320040" cy="411480"/>
+          </a:xfrm>
+          <a:prstGeom prst="rect">
+            <a:avLst/>
+          </a:prstGeom>
+          <a:noFill/>
+        </p:spPr>
+        <p:txBody>
+          <a:bodyPr wrap="square">
+            <a:spAutoFit/>
+          </a:bodyPr>
+          <a:lstStyle/>
+          <a:p>
+            <a:pPr>
+              <a:defRPr sz="1800" b="1">
+                <a:solidFill>
+                  <a:srgbClr val="3DDC84"/>
+                </a:solidFill>
+                <a:latin typeface="Arial"/>
+              </a:defRPr>
+            </a:pPr>
+            <a:r>
+              <a:t>1</a:t>
+            </a:r>
+          </a:p>
+        </p:txBody>
+      </p:sp>
+      <p:sp>
+        <p:nvSpPr>
+          <p:cNvPr id="6" name="TextBox 5"/>
+          <p:cNvSpPr txBox="1"/>
+          <p:nvPr/>
+        </p:nvSpPr>
+        <p:spPr>
+          <a:xfrm>
+            <a:off x="960120" y="2011680"/>
+            <a:ext cx="5120640" cy="502920"/>
+          </a:xfrm>
+          <a:prstGeom prst="rect">
+            <a:avLst/>
+          </a:prstGeom>
+          <a:noFill/>
+        </p:spPr>
+        <p:txBody>
+          <a:bodyPr wrap="square">
+            <a:spAutoFit/>
+          </a:bodyPr>
+          <a:lstStyle/>
+          <a:p>
+            <a:pPr>
+              <a:defRPr sz="1500" b="0">
+                <a:solidFill>
+                  <a:srgbClr val="F4F6F8"/>
+                </a:solidFill>
+                <a:latin typeface="Arial"/>
+              </a:defRPr>
+            </a:pPr>
+            <a:r>
+              <a:t>Pastikan meeting sudah check-in dan pill berstatus IN USE.</a:t>
+            </a:r>
+          </a:p>
+        </p:txBody>
+      </p:sp>
+      <p:sp>
+        <p:nvSpPr>
+          <p:cNvPr id="7" name="TextBox 6"/>
+          <p:cNvSpPr txBox="1"/>
+          <p:nvPr/>
+        </p:nvSpPr>
+        <p:spPr>
+          <a:xfrm>
+            <a:off x="594360" y="2578608"/>
+            <a:ext cx="320040" cy="411480"/>
+          </a:xfrm>
+          <a:prstGeom prst="rect">
+            <a:avLst/>
+          </a:prstGeom>
+          <a:noFill/>
+        </p:spPr>
+        <p:txBody>
+          <a:bodyPr wrap="square">
+            <a:spAutoFit/>
+          </a:bodyPr>
+          <a:lstStyle/>
+          <a:p>
+            <a:pPr>
+              <a:defRPr sz="1800" b="1">
+                <a:solidFill>
+                  <a:srgbClr val="3DDC84"/>
+                </a:solidFill>
+                <a:latin typeface="Arial"/>
+              </a:defRPr>
+            </a:pPr>
+            <a:r>
+              <a:t>2</a:t>
+            </a:r>
+          </a:p>
+        </p:txBody>
+      </p:sp>
+      <p:sp>
+        <p:nvSpPr>
+          <p:cNvPr id="8" name="TextBox 7"/>
+          <p:cNvSpPr txBox="1"/>
+          <p:nvPr/>
+        </p:nvSpPr>
+        <p:spPr>
+          <a:xfrm>
+            <a:off x="960120" y="2578608"/>
+            <a:ext cx="5120640" cy="502920"/>
+          </a:xfrm>
+          <a:prstGeom prst="rect">
+            <a:avLst/>
+          </a:prstGeom>
+          <a:noFill/>
+        </p:spPr>
+        <p:txBody>
+          <a:bodyPr wrap="square">
+            <a:spAutoFit/>
+          </a:bodyPr>
+          <a:lstStyle/>
+          <a:p>
+            <a:pPr>
+              <a:defRPr sz="1500" b="0">
+                <a:solidFill>
+                  <a:srgbClr val="F4F6F8"/>
+                </a:solidFill>
+                <a:latin typeface="Arial"/>
+              </a:defRPr>
+            </a:pPr>
+            <a:r>
+              <a:t>Tap pill IN USE sebanyak 5 kali dalam ±4 detik.</a:t>
+            </a:r>
+          </a:p>
+        </p:txBody>
+      </p:sp>
+      <p:sp>
+        <p:nvSpPr>
+          <p:cNvPr id="9" name="TextBox 8"/>
+          <p:cNvSpPr txBox="1"/>
+          <p:nvPr/>
+        </p:nvSpPr>
+        <p:spPr>
+          <a:xfrm>
+            <a:off x="594360" y="3145536"/>
+            <a:ext cx="320040" cy="411480"/>
+          </a:xfrm>
+          <a:prstGeom prst="rect">
+            <a:avLst/>
+          </a:prstGeom>
+          <a:noFill/>
+        </p:spPr>
+        <p:txBody>
+          <a:bodyPr wrap="square">
+            <a:spAutoFit/>
+          </a:bodyPr>
+          <a:lstStyle/>
+          <a:p>
+            <a:pPr>
+              <a:defRPr sz="1800" b="1">
+                <a:solidFill>
+                  <a:srgbClr val="3DDC84"/>
+                </a:solidFill>
+                <a:latin typeface="Arial"/>
+              </a:defRPr>
+            </a:pPr>
+            <a:r>
+              <a:t>3</a:t>
+            </a:r>
+          </a:p>
+        </p:txBody>
+      </p:sp>
+      <p:sp>
+        <p:nvSpPr>
+          <p:cNvPr id="10" name="TextBox 9"/>
+          <p:cNvSpPr txBox="1"/>
+          <p:nvPr/>
+        </p:nvSpPr>
+        <p:spPr>
+          <a:xfrm>
+            <a:off x="960120" y="3145536"/>
+            <a:ext cx="5120640" cy="502920"/>
+          </a:xfrm>
+          <a:prstGeom prst="rect">
+            <a:avLst/>
+          </a:prstGeom>
+          <a:noFill/>
+        </p:spPr>
+        <p:txBody>
+          <a:bodyPr wrap="square">
+            <a:spAutoFit/>
+          </a:bodyPr>
+          <a:lstStyle/>
+          <a:p>
+            <a:pPr>
+              <a:defRPr sz="1500" b="0">
+                <a:solidFill>
+                  <a:srgbClr val="F4F6F8"/>
+                </a:solidFill>
+                <a:latin typeface="Arial"/>
+              </a:defRPr>
+            </a:pPr>
+            <a:r>
+              <a:t>Tombol “Selesai” muncul di bawah pill.</a:t>
+            </a:r>
+          </a:p>
+        </p:txBody>
+      </p:sp>
+      <p:sp>
+        <p:nvSpPr>
+          <p:cNvPr id="11" name="TextBox 10"/>
+          <p:cNvSpPr txBox="1"/>
+          <p:nvPr/>
+        </p:nvSpPr>
+        <p:spPr>
+          <a:xfrm>
+            <a:off x="594360" y="3712464"/>
+            <a:ext cx="320040" cy="411480"/>
+          </a:xfrm>
+          <a:prstGeom prst="rect">
+            <a:avLst/>
+          </a:prstGeom>
+          <a:noFill/>
+        </p:spPr>
+        <p:txBody>
+          <a:bodyPr wrap="square">
+            <a:spAutoFit/>
+          </a:bodyPr>
+          <a:lstStyle/>
+          <a:p>
+            <a:pPr>
+              <a:defRPr sz="1800" b="1">
+                <a:solidFill>
+                  <a:srgbClr val="3DDC84"/>
+                </a:solidFill>
+                <a:latin typeface="Arial"/>
+              </a:defRPr>
+            </a:pPr>
+            <a:r>
+              <a:t>4</a:t>
+            </a:r>
+          </a:p>
+        </p:txBody>
+      </p:sp>
+      <p:sp>
+        <p:nvSpPr>
+          <p:cNvPr id="12" name="TextBox 11"/>
+          <p:cNvSpPr txBox="1"/>
+          <p:nvPr/>
+        </p:nvSpPr>
+        <p:spPr>
+          <a:xfrm>
+            <a:off x="960120" y="3712464"/>
+            <a:ext cx="5120640" cy="502920"/>
+          </a:xfrm>
+          <a:prstGeom prst="rect">
+            <a:avLst/>
+          </a:prstGeom>
+          <a:noFill/>
+        </p:spPr>
+        <p:txBody>
+          <a:bodyPr wrap="square">
+            <a:spAutoFit/>
+          </a:bodyPr>
+          <a:lstStyle/>
+          <a:p>
+            <a:pPr>
+              <a:defRPr sz="1500" b="0">
+                <a:solidFill>
+                  <a:srgbClr val="F4F6F8"/>
+                </a:solidFill>
+                <a:latin typeface="Arial"/>
+              </a:defRPr>
+            </a:pPr>
+            <a:r>
+              <a:t>Tap Selesai → konfirmasi → ruangan kembali AVAILABLE.</a:t>
+            </a:r>
+          </a:p>
+        </p:txBody>
+      </p:sp>
+      <p:sp>
+        <p:nvSpPr>
+          <p:cNvPr id="13" name="Rectangle 12"/>
+          <p:cNvSpPr/>
+          <p:nvPr/>
+        </p:nvSpPr>
+        <p:spPr>
+          <a:xfrm>
+            <a:off x="548640" y="4434840"/>
+            <a:ext cx="5669280" cy="1325880"/>
+          </a:xfrm>
+          <a:prstGeom prst="rect">
+            <a:avLst/>
+          </a:prstGeom>
+          <a:solidFill>
+            <a:srgbClr val="3A2A00"/>
+          </a:solidFill>
+          <a:ln>
+            <a:solidFill>
+              <a:srgbClr val="FFB800"/>
+            </a:solidFill>
+          </a:ln>
+        </p:spPr>
+        <p:style>
+          <a:lnRef idx="1">
+            <a:schemeClr val="accent1"/>
+          </a:lnRef>
+          <a:fillRef idx="3">
+            <a:schemeClr val="accent1"/>
+          </a:fillRef>
+          <a:effectRef idx="2">
+            <a:schemeClr val="accent1"/>
+          </a:effectRef>
+          <a:fontRef idx="minor">
+            <a:schemeClr val="lt1"/>
+          </a:fontRef>
+        </p:style>
+        <p:txBody>
+          <a:bodyPr rtlCol="0" anchor="ctr" wrap="square"/>
+          <a:lstStyle/>
+          <a:p>
+            <a:pPr>
+              <a:defRPr b="1" sz="1400">
+                <a:solidFill>
+                  <a:srgbClr val="FFD25A"/>
+                </a:solidFill>
+                <a:latin typeface="Arial"/>
+              </a:defRPr>
+            </a:pPr>
+            <a:r>
+              <a:t>Check-in lebih awal dari jam mulai?</a:t>
+            </a:r>
+          </a:p>
+          <a:p>
+            <a:pPr>
+              <a:defRPr sz="1200">
+                <a:solidFill>
+                  <a:srgbClr val="F4F6F8"/>
+                </a:solidFill>
+                <a:latin typeface="Arial"/>
+              </a:defRPr>
+            </a:pPr>
+            <a:r>
+              <a:t>5 tap tetap dilakukan, tetapi kiosk hanya menampilkan “Selesai aktif pukul HH:MM”. Tombol Selesai baru bisa dipakai setelah jam mulai.</a:t>
+            </a:r>
+          </a:p>
+        </p:txBody>
+      </p:sp>
+      <p:sp>
+        <p:nvSpPr>
+          <p:cNvPr id="14" name="TextBox 13"/>
+          <p:cNvSpPr txBox="1"/>
+          <p:nvPr/>
+        </p:nvSpPr>
+        <p:spPr>
+          <a:xfrm>
+            <a:off x="548640" y="5989320"/>
+            <a:ext cx="5760720" cy="457200"/>
+          </a:xfrm>
+          <a:prstGeom prst="rect">
+            <a:avLst/>
+          </a:prstGeom>
+          <a:noFill/>
+        </p:spPr>
+        <p:txBody>
+          <a:bodyPr wrap="square">
+            <a:spAutoFit/>
+          </a:bodyPr>
+          <a:lstStyle/>
+          <a:p>
+            <a:pPr>
+              <a:defRPr sz="1100" b="0">
+                <a:solidFill>
+                  <a:srgbClr val="A9B3BF"/>
+                </a:solidFill>
+                <a:latin typeface="Arial"/>
+              </a:defRPr>
+            </a:pPr>
+            <a:r>
+              <a:t>Admin IT: jangan tutup/restart aplikasi untuk menyelesaikan meeting. Gunakan 5 tap pill; Cancel di CMS hanya untuk booking yang salah.</a:t>
+            </a:r>
+          </a:p>
+        </p:txBody>
+      </p:sp>
+      <p:pic>
+        <p:nvPicPr>
+          <p:cNvPr id="15" name="Picture 14" descr="flow-finish-btn.png"/>
+          <p:cNvPicPr>
+            <a:picLocks noChangeAspect="1"/>
+          </p:cNvPicPr>
+          <p:nvPr/>
+        </p:nvPicPr>
+        <p:blipFill>
+          <a:blip r:embed="rId2"/>
+          <a:stretch>
+            <a:fillRect/>
+          </a:stretch>
+        </p:blipFill>
+        <p:spPr>
+          <a:xfrm>
+            <a:off x="6446520" y="1920240"/>
+            <a:ext cx="5074920" cy="3171825"/>
+          </a:xfrm>
+          <a:prstGeom prst="rect">
+            <a:avLst/>
+          </a:prstGeom>
+        </p:spPr>
+      </p:pic>
+      <p:sp>
+        <p:nvSpPr>
+          <p:cNvPr id="16" name="TextBox 15"/>
+          <p:cNvSpPr txBox="1"/>
+          <p:nvPr/>
+        </p:nvSpPr>
+        <p:spPr>
+          <a:xfrm>
+            <a:off x="6446520" y="5806440"/>
+            <a:ext cx="5074920" cy="320040"/>
+          </a:xfrm>
+          <a:prstGeom prst="rect">
+            <a:avLst/>
+          </a:prstGeom>
+          <a:noFill/>
+        </p:spPr>
+        <p:txBody>
+          <a:bodyPr wrap="square">
+            <a:spAutoFit/>
+          </a:bodyPr>
+          <a:lstStyle/>
+          <a:p>
+            <a:pPr>
+              <a:defRPr sz="1100" b="0">
+                <a:solidFill>
+                  <a:srgbClr val="A9B3BF"/>
+                </a:solidFill>
+                <a:latin typeface="Arial"/>
+              </a:defRPr>
+            </a:pPr>
+            <a:r>
+              <a:t>Tombol Selesai muncul setelah 5 tap pill IN USE.</a:t>
+            </a:r>
+          </a:p>
+        </p:txBody>
+      </p:sp>
+    </p:spTree>
+  </p:cSld>
+  <p:clrMapOvr>
+    <a:masterClrMapping/>
+  </p:clrMapOvr>
+</p:sld>
+</file>
+
 <file path=ppt/slides/slide2.xml><?xml version="1.0" encoding="utf-8"?>
 <p:sld xmlns:a="http://schemas.openxmlformats.org/drawingml/2006/main" xmlns:p="http://schemas.openxmlformats.org/presentationml/2006/main" xmlns:r="http://schemas.openxmlformats.org/officeDocument/2006/relationships">
   <p:cSld>
@@ -11017,7 +11674,7 @@
                 </a:solidFill>
                 <a:latin typeface="Arial"/>
               </a:rPr>
-              <a:t>2 / 16</a:t>
+              <a:t>2 / 17</a:t>
             </a:r>
           </a:p>
         </p:txBody>
@@ -11938,7 +12595,7 @@
                 </a:solidFill>
                 <a:latin typeface="Arial"/>
               </a:rPr>
-              <a:t>3 / 16</a:t>
+              <a:t>3 / 17</a:t>
             </a:r>
           </a:p>
         </p:txBody>
@@ -12650,7 +13307,7 @@
                 </a:solidFill>
                 <a:latin typeface="Arial"/>
               </a:rPr>
-              <a:t>4 / 16</a:t>
+              <a:t>4 / 17</a:t>
             </a:r>
           </a:p>
         </p:txBody>
@@ -13269,7 +13926,7 @@
                 </a:solidFill>
                 <a:latin typeface="Arial"/>
               </a:rPr>
-              <a:t>5 / 16</a:t>
+              <a:t>5 / 17</a:t>
             </a:r>
           </a:p>
         </p:txBody>
@@ -13849,7 +14506,7 @@
                 </a:solidFill>
                 <a:latin typeface="Arial"/>
               </a:rPr>
-              <a:t>6 / 16</a:t>
+              <a:t>6 / 17</a:t>
             </a:r>
           </a:p>
         </p:txBody>
@@ -14399,7 +15056,7 @@
                 </a:solidFill>
                 <a:latin typeface="Arial"/>
               </a:rPr>
-              <a:t>7 / 16</a:t>
+              <a:t>7 / 17</a:t>
             </a:r>
           </a:p>
         </p:txBody>
@@ -14949,7 +15606,7 @@
                 </a:solidFill>
                 <a:latin typeface="Arial"/>
               </a:rPr>
-              <a:t>8 / 16</a:t>
+              <a:t>8 / 17</a:t>
             </a:r>
           </a:p>
         </p:txBody>
@@ -15628,7 +16285,7 @@
                 </a:solidFill>
                 <a:latin typeface="Arial"/>
               </a:rPr>
-              <a:t>9 / 16</a:t>
+              <a:t>9 / 17</a:t>
             </a:r>
           </a:p>
         </p:txBody>

</xml_diff>

<commit_message>
feat(kiosk): publish semi-auto APK update manifest
</commit_message>
<xml_diff>
--- a/docs/training/RoomBooking-Panduan-CMS-Tablet.pptx
+++ b/docs/training/RoomBooking-Panduan-CMS-Tablet.pptx
@@ -5050,7 +5050,7 @@
                 </a:solidFill>
                 <a:latin typeface="Arial"/>
               </a:rPr>
-              <a:t>APK 1.3.9 (20)</a:t>
+              <a:t>APK 1.4.0 (21)</a:t>
             </a:r>
           </a:p>
         </p:txBody>
@@ -5253,7 +5253,7 @@
                 </a:solidFill>
                 <a:latin typeface="Arial"/>
               </a:rPr>
-              <a:t>Tablet ruangan dalam status AVAILABLE (APK 1.3.9).</a:t>
+              <a:t>Tablet ruangan dalam status AVAILABLE (APK 1.4.0).</a:t>
             </a:r>
           </a:p>
         </p:txBody>
@@ -10095,7 +10095,7 @@
               </a:defRPr>
             </a:pPr>
             <a:r>
-              <a:t>Buka aplikasi kiosk dan cek footer: v1.3.9 (20) · CMS 3.12.0.</a:t>
+              <a:t>Buka aplikasi kiosk dan cek footer: v1.4.0 (21) · CMS 3.12.0.</a:t>
             </a:r>
           </a:p>
         </p:txBody>
@@ -10222,7 +10222,7 @@
               </a:defRPr>
             </a:pPr>
             <a:r>
-              <a:t>Rilis saat ini: 1.3.9 (20)</a:t>
+              <a:t>Rilis saat ini: 1.4.0 (21)</a:t>
             </a:r>
           </a:p>
           <a:p>
@@ -10235,7 +10235,7 @@
               </a:defRPr>
             </a:pPr>
             <a:r>
-              <a:t>Build tag 1.3.9-20-f7c5d22. Unduh hanya dari server sendiri — jangan pakai file dari chat atau email. Catat versi yang dipasang di buku serah terima.</a:t>
+              <a:t>Build tag 1.4.0-21-a269e73. Unduh hanya dari server sendiri — jangan pakai file dari chat atau email. Catat versi yang dipasang di buku serah terima.</a:t>
             </a:r>
           </a:p>
         </p:txBody>
@@ -16775,7 +16775,7 @@
                 </a:solidFill>
                 <a:latin typeface="Arial"/>
               </a:rPr>
-              <a:t>APK 1.3.9 (20)</a:t>
+              <a:t>APK 1.4.0 (21)</a:t>
             </a:r>
           </a:p>
         </p:txBody>

</xml_diff>

<commit_message>
chore: sync clean snapshot dengan master
</commit_message>
<xml_diff>
--- a/docs/training/RoomBooking-Panduan-CMS-Tablet.pptx
+++ b/docs/training/RoomBooking-Panduan-CMS-Tablet.pptx
@@ -5050,7 +5050,7 @@
                 </a:solidFill>
                 <a:latin typeface="Arial"/>
               </a:rPr>
-              <a:t>APK 1.3.9 (20)</a:t>
+              <a:t>APK 1.4.0 (21)</a:t>
             </a:r>
           </a:p>
         </p:txBody>
@@ -5253,7 +5253,7 @@
                 </a:solidFill>
                 <a:latin typeface="Arial"/>
               </a:rPr>
-              <a:t>Tablet ruangan dalam status AVAILABLE (APK 1.3.9).</a:t>
+              <a:t>Tablet ruangan dalam status AVAILABLE (APK 1.4.0).</a:t>
             </a:r>
           </a:p>
         </p:txBody>
@@ -10095,7 +10095,7 @@
               </a:defRPr>
             </a:pPr>
             <a:r>
-              <a:t>Buka aplikasi kiosk dan cek footer: v1.3.9 (20) · CMS 3.12.0.</a:t>
+              <a:t>Buka aplikasi kiosk dan cek footer: v1.4.0 (21) · CMS 3.12.0.</a:t>
             </a:r>
           </a:p>
         </p:txBody>
@@ -10222,7 +10222,7 @@
               </a:defRPr>
             </a:pPr>
             <a:r>
-              <a:t>Rilis saat ini: 1.3.9 (20)</a:t>
+              <a:t>Rilis saat ini: 1.4.0 (21)</a:t>
             </a:r>
           </a:p>
           <a:p>
@@ -10235,7 +10235,7 @@
               </a:defRPr>
             </a:pPr>
             <a:r>
-              <a:t>Build tag 1.3.9-20-f7c5d22. Unduh hanya dari server sendiri — jangan pakai file dari chat atau email. Catat versi yang dipasang di buku serah terima.</a:t>
+              <a:t>Build tag 1.4.0-21-a269e73. Unduh hanya dari server sendiri — jangan pakai file dari chat atau email. Catat versi yang dipasang di buku serah terima.</a:t>
             </a:r>
           </a:p>
         </p:txBody>
@@ -16775,7 +16775,7 @@
                 </a:solidFill>
                 <a:latin typeface="Arial"/>
               </a:rPr>
-              <a:t>APK 1.3.9 (20)</a:t>
+              <a:t>APK 1.4.0 (21)</a:t>
             </a:r>
           </a:p>
         </p:txBody>

</xml_diff>

<commit_message>
fix(calendar): let receptionists manage floor bookings
</commit_message>
<xml_diff>
--- a/docs/training/RoomBooking-Panduan-CMS-Tablet.pptx
+++ b/docs/training/RoomBooking-Panduan-CMS-Tablet.pptx
@@ -5050,7 +5050,7 @@
                 </a:solidFill>
                 <a:latin typeface="Arial"/>
               </a:rPr>
-              <a:t>APK 1.4.0 (21)</a:t>
+              <a:t>APK 1.4.1 (22)</a:t>
             </a:r>
           </a:p>
         </p:txBody>
@@ -5253,7 +5253,7 @@
                 </a:solidFill>
                 <a:latin typeface="Arial"/>
               </a:rPr>
-              <a:t>Tablet ruangan dalam status AVAILABLE (APK 1.4.0).</a:t>
+              <a:t>Tablet ruangan dalam status AVAILABLE (APK 1.4.1).</a:t>
             </a:r>
           </a:p>
         </p:txBody>
@@ -10095,7 +10095,7 @@
               </a:defRPr>
             </a:pPr>
             <a:r>
-              <a:t>Buka aplikasi kiosk dan cek footer: v1.4.0 (21) · CMS 3.12.0.</a:t>
+              <a:t>Buka aplikasi kiosk dan cek footer: v1.4.1 (22) · CMS 3.12.0.</a:t>
             </a:r>
           </a:p>
         </p:txBody>
@@ -10222,7 +10222,7 @@
               </a:defRPr>
             </a:pPr>
             <a:r>
-              <a:t>Rilis saat ini: 1.4.0 (21)</a:t>
+              <a:t>Rilis saat ini: 1.4.1 (22)</a:t>
             </a:r>
           </a:p>
           <a:p>
@@ -10235,7 +10235,7 @@
               </a:defRPr>
             </a:pPr>
             <a:r>
-              <a:t>Build tag 1.4.0-21-a269e73. Unduh hanya dari server sendiri — jangan pakai file dari chat atau email. Catat versi yang dipasang di buku serah terima.</a:t>
+              <a:t>Build tag 1.4.1-22-3b79432. Unduh hanya dari server sendiri — jangan pakai file dari chat atau email. Catat versi yang dipasang di buku serah terima.</a:t>
             </a:r>
           </a:p>
         </p:txBody>
@@ -16775,7 +16775,7 @@
                 </a:solidFill>
                 <a:latin typeface="Arial"/>
               </a:rPr>
-              <a:t>APK 1.4.0 (21)</a:t>
+              <a:t>APK 1.4.1 (22)</a:t>
             </a:r>
           </a:p>
         </p:txBody>

</xml_diff>

<commit_message>
feat(apk): expose update in tablet menu and publish 1.4.2
</commit_message>
<xml_diff>
--- a/docs/training/RoomBooking-Panduan-CMS-Tablet.pptx
+++ b/docs/training/RoomBooking-Panduan-CMS-Tablet.pptx
@@ -5050,7 +5050,7 @@
                 </a:solidFill>
                 <a:latin typeface="Arial"/>
               </a:rPr>
-              <a:t>APK 1.4.1 (22)</a:t>
+              <a:t>APK 1.4.2 (23)</a:t>
             </a:r>
           </a:p>
         </p:txBody>
@@ -5253,7 +5253,7 @@
                 </a:solidFill>
                 <a:latin typeface="Arial"/>
               </a:rPr>
-              <a:t>Tablet ruangan dalam status AVAILABLE (APK 1.4.1).</a:t>
+              <a:t>Tablet ruangan dalam status AVAILABLE (APK 1.4.2).</a:t>
             </a:r>
           </a:p>
         </p:txBody>
@@ -10095,7 +10095,7 @@
               </a:defRPr>
             </a:pPr>
             <a:r>
-              <a:t>Buka aplikasi kiosk dan cek footer: v1.4.1 (22) · CMS 3.12.0.</a:t>
+              <a:t>Buka aplikasi kiosk dan cek footer: v1.4.2 (23) · CMS 3.12.0.</a:t>
             </a:r>
           </a:p>
         </p:txBody>
@@ -10222,7 +10222,7 @@
               </a:defRPr>
             </a:pPr>
             <a:r>
-              <a:t>Rilis saat ini: 1.4.1 (22)</a:t>
+              <a:t>Rilis saat ini: 1.4.2 (23)</a:t>
             </a:r>
           </a:p>
           <a:p>
@@ -10235,7 +10235,7 @@
               </a:defRPr>
             </a:pPr>
             <a:r>
-              <a:t>Build tag 1.4.1-22-3b79432. Unduh hanya dari server sendiri — jangan pakai file dari chat atau email. Catat versi yang dipasang di buku serah terima.</a:t>
+              <a:t>Build tag 1.4.2-23-2bfdbff. Unduh hanya dari server sendiri — jangan pakai file dari chat atau email. Catat versi yang dipasang di buku serah terima.</a:t>
             </a:r>
           </a:p>
         </p:txBody>
@@ -16775,7 +16775,7 @@
                 </a:solidFill>
                 <a:latin typeface="Arial"/>
               </a:rPr>
-              <a:t>APK 1.4.1 (22)</a:t>
+              <a:t>APK 1.4.2 (23)</a:t>
             </a:r>
           </a:p>
         </p:txBody>

</xml_diff>

<commit_message>
feat(apk): add update check to tablet menu and publish 1.4.3
</commit_message>
<xml_diff>
--- a/docs/training/RoomBooking-Panduan-CMS-Tablet.pptx
+++ b/docs/training/RoomBooking-Panduan-CMS-Tablet.pptx
@@ -5050,7 +5050,7 @@
                 </a:solidFill>
                 <a:latin typeface="Arial"/>
               </a:rPr>
-              <a:t>APK 1.4.2 (23)</a:t>
+              <a:t>APK 1.4.3 (24)</a:t>
             </a:r>
           </a:p>
         </p:txBody>
@@ -5253,7 +5253,7 @@
                 </a:solidFill>
                 <a:latin typeface="Arial"/>
               </a:rPr>
-              <a:t>Tablet ruangan dalam status AVAILABLE (APK 1.4.2).</a:t>
+              <a:t>Tablet ruangan dalam status AVAILABLE (APK 1.4.3).</a:t>
             </a:r>
           </a:p>
         </p:txBody>
@@ -10095,7 +10095,7 @@
               </a:defRPr>
             </a:pPr>
             <a:r>
-              <a:t>Buka aplikasi kiosk dan cek footer: v1.4.2 (23) · CMS 3.12.0.</a:t>
+              <a:t>Buka aplikasi kiosk dan cek footer: v1.4.3 (24) · CMS 3.12.0.</a:t>
             </a:r>
           </a:p>
         </p:txBody>
@@ -10222,7 +10222,7 @@
               </a:defRPr>
             </a:pPr>
             <a:r>
-              <a:t>Rilis saat ini: 1.4.2 (23)</a:t>
+              <a:t>Rilis saat ini: 1.4.3 (24)</a:t>
             </a:r>
           </a:p>
           <a:p>
@@ -10235,7 +10235,7 @@
               </a:defRPr>
             </a:pPr>
             <a:r>
-              <a:t>Build tag 1.4.2-23-2bfdbff. Unduh hanya dari server sendiri — jangan pakai file dari chat atau email. Catat versi yang dipasang di buku serah terima.</a:t>
+              <a:t>Build tag 1.4.3-24-c131edb. Unduh hanya dari server sendiri — jangan pakai file dari chat atau email. Catat versi yang dipasang di buku serah terima.</a:t>
             </a:r>
           </a:p>
         </p:txBody>
@@ -16775,7 +16775,7 @@
                 </a:solidFill>
                 <a:latin typeface="Arial"/>
               </a:rPr>
-              <a:t>APK 1.4.2 (23)</a:t>
+              <a:t>APK 1.4.3 (24)</a:t>
             </a:r>
           </a:p>
         </p:txBody>

</xml_diff>

<commit_message>
feat: add about and license pages for CMS and kiosk
</commit_message>
<xml_diff>
--- a/docs/training/RoomBooking-Panduan-CMS-Tablet.pptx
+++ b/docs/training/RoomBooking-Panduan-CMS-Tablet.pptx
@@ -5050,7 +5050,7 @@
                 </a:solidFill>
                 <a:latin typeface="Arial"/>
               </a:rPr>
-              <a:t>APK 1.4.3 (24)</a:t>
+              <a:t>APK 1.4.4 (25)</a:t>
             </a:r>
           </a:p>
         </p:txBody>
@@ -5253,7 +5253,7 @@
                 </a:solidFill>
                 <a:latin typeface="Arial"/>
               </a:rPr>
-              <a:t>Tablet ruangan dalam status AVAILABLE (APK 1.4.3).</a:t>
+              <a:t>Tablet ruangan dalam status AVAILABLE (APK 1.4.4).</a:t>
             </a:r>
           </a:p>
         </p:txBody>
@@ -10095,7 +10095,7 @@
               </a:defRPr>
             </a:pPr>
             <a:r>
-              <a:t>Buka aplikasi kiosk dan cek footer: v1.4.3 (24) · CMS 3.12.0.</a:t>
+              <a:t>Buka aplikasi kiosk dan cek footer: v1.4.4 (25) · CMS 3.12.0.</a:t>
             </a:r>
           </a:p>
         </p:txBody>
@@ -10222,7 +10222,7 @@
               </a:defRPr>
             </a:pPr>
             <a:r>
-              <a:t>Rilis saat ini: 1.4.3 (24)</a:t>
+              <a:t>Rilis saat ini: 1.4.4 (25)</a:t>
             </a:r>
           </a:p>
           <a:p>
@@ -10235,7 +10235,7 @@
               </a:defRPr>
             </a:pPr>
             <a:r>
-              <a:t>Build tag 1.4.3-24-c131edb. Unduh hanya dari server sendiri — jangan pakai file dari chat atau email. Catat versi yang dipasang di buku serah terima.</a:t>
+              <a:t>Build tag 1.4.4-25-04c7d80. Unduh hanya dari server sendiri — jangan pakai file dari chat atau email. Catat versi yang dipasang di buku serah terima.</a:t>
             </a:r>
           </a:p>
         </p:txBody>
@@ -16775,7 +16775,7 @@
                 </a:solidFill>
                 <a:latin typeface="Arial"/>
               </a:rPr>
-              <a:t>APK 1.4.3 (24)</a:t>
+              <a:t>APK 1.4.4 (25)</a:t>
             </a:r>
           </a:p>
         </p:txBody>

</xml_diff>

<commit_message>
docs(training): use APK 1.4.5 tablet screenshots
</commit_message>
<xml_diff>
--- a/docs/training/RoomBooking-Panduan-CMS-Tablet.pptx
+++ b/docs/training/RoomBooking-Panduan-CMS-Tablet.pptx
@@ -18418,7 +18418,7 @@
         <p:spPr>
           <a:xfrm>
             <a:off x="6858000" y="1737360"/>
-            <a:ext cx="4297679" cy="2810625"/>
+            <a:ext cx="4297679" cy="2493829"/>
           </a:xfrm>
           <a:prstGeom prst="roundRect">
             <a:avLst>
@@ -18474,7 +18474,7 @@
         <p:spPr>
           <a:xfrm>
             <a:off x="6903720" y="1783080"/>
-            <a:ext cx="4206240" cy="2719185"/>
+            <a:ext cx="4206240" cy="2402389"/>
           </a:xfrm>
           <a:prstGeom prst="rect">
             <a:avLst/>
@@ -20892,7 +20892,7 @@
                 </a:solidFill>
                 <a:latin typeface="Arial"/>
               </a:rPr>
-              <a:t>Foto asli tablet UAT. Subjek meeting pada foto disamarkan; versi saat ini APK 1.4.5.</a:t>
+              <a:t>Screenshot APK 1.4.5 dari UAT; nama organizer disamarkan menjadi “Tim”.</a:t>
             </a:r>
           </a:p>
         </p:txBody>
@@ -21067,7 +21067,7 @@
         <p:spPr>
           <a:xfrm>
             <a:off x="548640" y="1737360"/>
-            <a:ext cx="3337560" cy="2189941"/>
+            <a:ext cx="3337560" cy="1945457"/>
           </a:xfrm>
           <a:prstGeom prst="roundRect">
             <a:avLst>
@@ -21123,7 +21123,7 @@
         <p:spPr>
           <a:xfrm>
             <a:off x="594360" y="1783080"/>
-            <a:ext cx="3246120" cy="2098502"/>
+            <a:ext cx="3246120" cy="1854018"/>
           </a:xfrm>
           <a:prstGeom prst="rect">
             <a:avLst/>
@@ -21217,7 +21217,7 @@
         <p:spPr>
           <a:xfrm>
             <a:off x="3886200" y="1737360"/>
-            <a:ext cx="3337560" cy="2183752"/>
+            <a:ext cx="3337560" cy="1945457"/>
           </a:xfrm>
           <a:prstGeom prst="roundRect">
             <a:avLst>
@@ -21273,7 +21273,7 @@
         <p:spPr>
           <a:xfrm>
             <a:off x="3931920" y="1783080"/>
-            <a:ext cx="3246120" cy="2092312"/>
+            <a:ext cx="3246120" cy="1854018"/>
           </a:xfrm>
           <a:prstGeom prst="rect">
             <a:avLst/>
@@ -21367,7 +21367,7 @@
         <p:spPr>
           <a:xfrm>
             <a:off x="7223760" y="1737360"/>
-            <a:ext cx="3337560" cy="2169563"/>
+            <a:ext cx="3337560" cy="1945457"/>
           </a:xfrm>
           <a:prstGeom prst="roundRect">
             <a:avLst>
@@ -21423,7 +21423,7 @@
         <p:spPr>
           <a:xfrm>
             <a:off x="7269480" y="1783080"/>
-            <a:ext cx="3246120" cy="2078124"/>
+            <a:ext cx="3246120" cy="1854018"/>
           </a:xfrm>
           <a:prstGeom prst="rect">
             <a:avLst/>
@@ -21710,7 +21710,7 @@
                 </a:solidFill>
                 <a:latin typeface="Arial"/>
               </a:rPr>
-              <a:t>Foto diambil pada perangkat UAT; tampilan versi 1.4.5 tetap memakai warna dan alur yang sama.</a:t>
+              <a:t>Screenshot langsung dari APK 1.4.5 (26) di UAT; data uji, bukan data produksi.</a:t>
             </a:r>
           </a:p>
         </p:txBody>

</xml_diff>